<commit_message>
Añade el correo como canal de contacto del agente
Co-Authored-By: Claude Opus 5.5 <noreply@anthropic.com>
Claude-Session: https://claude.ai/code/session_012mMHWqjhs78dxJpdvnbg1r
</commit_message>
<xml_diff>
--- a/docs/Ryvai-propuesta-de-valor.pptx
+++ b/docs/Ryvai-propuesta-de-valor.pptx
@@ -117,40 +117,40 @@
   <p:extLst>
     <p:ext uri="{521415D9-36F7-43E2-AB2F-B90AF26B5E84}">
       <p14:sectionLst xmlns:p14="http://schemas.microsoft.com/office/powerpoint/2010/main">
-        <p14:section name="Portada" id="{d8c2e71a-4f30-2cb7-717b-7c22d395e836}">
+        <p14:section name="Portada" id="{16f958a2-3aad-80a3-4e28-5da3d456363f}">
           <p14:sldIdLst>
             <p14:sldId id="256"/>
           </p14:sldIdLst>
         </p14:section>
-        <p14:section name="Problema" id="{7b4ca800-6770-e207-c894-9941803bb71c}">
+        <p14:section name="Problema" id="{35f74bd4-3d1b-38d0-d392-f317b7cc3965}">
           <p14:sldIdLst>
             <p14:sldId id="257"/>
           </p14:sldIdLst>
         </p14:section>
-        <p14:section name="Solución" id="{d75862c4-ff2f-f26a-19e9-a7141e91acf8}">
+        <p14:section name="Solución" id="{7969037c-060c-2bc3-b417-2d431942d75e}">
           <p14:sldIdLst>
             <p14:sldId id="258"/>
             <p14:sldId id="259"/>
           </p14:sldIdLst>
         </p14:section>
-        <p14:section name="Valor" id="{b371e0ee-a26d-a3ee-ad08-558e7bbf0960}">
+        <p14:section name="Valor" id="{991faabf-841d-c58f-2419-c8dca66789d3}">
           <p14:sldIdLst>
             <p14:sldId id="260"/>
             <p14:sldId id="261"/>
           </p14:sldIdLst>
         </p14:section>
-        <p14:section name="Resultados" id="{3f91e110-3537-e8c3-6839-eec147cd4697}">
+        <p14:section name="Resultados" id="{df6d9204-b971-76c3-99cf-3617997e9400}">
           <p14:sldIdLst>
             <p14:sldId id="262"/>
             <p14:sldId id="263"/>
           </p14:sldIdLst>
         </p14:section>
-        <p14:section name="Diferencia" id="{bc564922-a65f-8b41-c5be-65786e5cf195}">
+        <p14:section name="Diferencia" id="{a6769eb6-ef7a-0bca-c86a-dbcd2dc813d6}">
           <p14:sldIdLst>
             <p14:sldId id="264"/>
           </p14:sldIdLst>
         </p14:section>
-        <p14:section name="Piloto" id="{181a9fc9-1f9a-9203-0935-719790e0dccc}">
+        <p14:section name="Piloto" id="{69826a73-e7fc-fde2-a397-143eb512eb25}">
           <p14:sldIdLst>
             <p14:sldId id="265"/>
             <p14:sldId id="266"/>
@@ -3664,7 +3664,7 @@
                   <a:schemeClr val="accent4"/>
                 </a:solidFill>
               </a:rPr>
-              <a:t>acceso al ERP, un número de WhatsApp Business y una persona de referencia unos minutos al día para resolver los casos atascados.</a:t>
+              <a:t>acceso al ERP, un número de WhatsApp Business, una dirección de correo para pedidos y una persona de referencia unos minutos al día para resolver los casos atascados.</a:t>
             </a:r>
             <a:endParaRPr lang="en-US" sz="1500" dirty="0"/>
           </a:p>
@@ -4923,7 +4923,7 @@
                   <a:schemeClr val="accent4"/>
                 </a:solidFill>
               </a:rPr>
-              <a:t>Escribe por WhatsApp o llama, en un tono cercano y natural. Entiende notas de voz.</a:t>
+              <a:t>Escribe por WhatsApp o correo, o llama, en un tono cercano. Entiende notas de voz.</a:t>
             </a:r>
             <a:endParaRPr lang="en-US" sz="1400" dirty="0"/>
           </a:p>
@@ -6465,7 +6465,7 @@
                   <a:schemeClr val="accent4"/>
                 </a:solidFill>
               </a:rPr>
-              <a:t>Los pedidos habituales se confirman y se registran en el ERP solos, por WhatsApp o por teléfono.</a:t>
+              <a:t>Los pedidos habituales se confirman y se registran en el ERP solos, por WhatsApp, correo o teléfono.</a:t>
             </a:r>
             <a:endParaRPr lang="en-US" sz="1400" dirty="0"/>
           </a:p>
@@ -9877,7 +9877,7 @@
                             <a:schemeClr val="accent1"/>
                           </a:solidFill>
                         </a:rPr>
-                        <a:t>Sí, por WhatsApp y llamada</a:t>
+                        <a:t>Sí, por WhatsApp, correo y llamada</a:t>
                       </a:r>
                       <a:endParaRPr lang="en-US" sz="1300" dirty="0"/>
                     </a:p>

</xml_diff>